<commit_message>
docs: update company name to IronBit OOO and location to Omsk in MTC documents
Changed all references from ImagingTools GmbH to IronBit OOO
and from Stockdorf/Штокдорф, Germany to Омск, Россия
in both PDF and PPTX product description documents.

Agent-Logs-Url: https://github.com/ImagingTools/ProLife/sessions/d9d4aa3b-6c5a-4300-b179-cd3554a83bb4

Co-authored-by: kirill-lepski <250310555+kirill-lepski@users.noreply.github.com>
</commit_message>
<xml_diff>
--- a/Docs/ProLife_Product_Description_MTC.pptx
+++ b/Docs/ProLife_Product_Description_MTC.pptx
@@ -3216,7 +3216,7 @@
               </a:defRPr>
             </a:pPr>
             <a:r>
-              <a:t>ImagingTools GmbH</a:t>
+              <a:t>IronBit OOO</a:t>
             </a:r>
           </a:p>
         </p:txBody>
@@ -3324,7 +3324,7 @@
               </a:defRPr>
             </a:pPr>
             <a:r>
-              <a:t>Штокдорф, Германия · Апрель 2026</a:t>
+              <a:t>Омск, Россия · Апрель 2026</a:t>
             </a:r>
           </a:p>
         </p:txBody>
@@ -3478,6 +3478,78 @@
         <p:spPr>
           <a:xfrm>
             <a:off x="731520" y="1463040"/>
+            <a:ext cx="5029200" cy="365760"/>
+          </a:xfrm>
+          <a:prstGeom prst="rect">
+            <a:avLst/>
+          </a:prstGeom>
+          <a:noFill/>
+        </p:spPr>
+        <p:txBody>
+          <a:bodyPr wrap="square">
+            <a:spAutoFit/>
+          </a:bodyPr>
+          <a:lstStyle/>
+          <a:p>
+            <a:pPr algn="l">
+              <a:defRPr sz="2000" b="1">
+                <a:solidFill>
+                  <a:srgbClr val="2980B9"/>
+                </a:solidFill>
+                <a:latin typeface="Calibri"/>
+              </a:defRPr>
+            </a:pPr>
+            <a:r>
+              <a:t>Безопасность</a:t>
+            </a:r>
+          </a:p>
+        </p:txBody>
+      </p:sp>
+      <p:sp>
+        <p:nvSpPr>
+          <p:cNvPr id="6" name="TextBox 5"/>
+          <p:cNvSpPr txBox="1"/>
+          <p:nvPr/>
+        </p:nvSpPr>
+        <p:spPr>
+          <a:xfrm>
+            <a:off x="6400800" y="1463040"/>
+            <a:ext cx="5029200" cy="365760"/>
+          </a:xfrm>
+          <a:prstGeom prst="rect">
+            <a:avLst/>
+          </a:prstGeom>
+          <a:noFill/>
+        </p:spPr>
+        <p:txBody>
+          <a:bodyPr wrap="square">
+            <a:spAutoFit/>
+          </a:bodyPr>
+          <a:lstStyle/>
+          <a:p>
+            <a:pPr algn="l">
+              <a:defRPr sz="2000" b="1">
+                <a:solidFill>
+                  <a:srgbClr val="2980B9"/>
+                </a:solidFill>
+                <a:latin typeface="Calibri"/>
+              </a:defRPr>
+            </a:pPr>
+            <a:r>
+              <a:t>CI/CD и автоматизация</a:t>
+            </a:r>
+          </a:p>
+        </p:txBody>
+      </p:sp>
+      <p:sp>
+        <p:nvSpPr>
+          <p:cNvPr id="7" name="TextBox 6"/>
+          <p:cNvSpPr txBox="1"/>
+          <p:nvPr/>
+        </p:nvSpPr>
+        <p:spPr>
+          <a:xfrm>
+            <a:off x="731520" y="2011680"/>
             <a:ext cx="5029200" cy="4572000"/>
           </a:xfrm>
           <a:prstGeom prst="rect">
@@ -3613,13 +3685,13 @@
       </p:sp>
       <p:sp>
         <p:nvSpPr>
-          <p:cNvPr id="6" name="TextBox 5"/>
+          <p:cNvPr id="8" name="TextBox 7"/>
           <p:cNvSpPr txBox="1"/>
           <p:nvPr/>
         </p:nvSpPr>
         <p:spPr>
           <a:xfrm>
-            <a:off x="6400800" y="1463040"/>
+            <a:off x="6400800" y="2011680"/>
             <a:ext cx="5029200" cy="4572000"/>
           </a:xfrm>
           <a:prstGeom prst="rect">
@@ -3732,78 +3804,6 @@
             </a:pPr>
             <a:r>
               <a:t>Валидация SBOM при каждой сборке</a:t>
-            </a:r>
-          </a:p>
-        </p:txBody>
-      </p:sp>
-      <p:sp>
-        <p:nvSpPr>
-          <p:cNvPr id="7" name="TextBox 6"/>
-          <p:cNvSpPr txBox="1"/>
-          <p:nvPr/>
-        </p:nvSpPr>
-        <p:spPr>
-          <a:xfrm>
-            <a:off x="731520" y="1463040"/>
-            <a:ext cx="5029200" cy="365760"/>
-          </a:xfrm>
-          <a:prstGeom prst="rect">
-            <a:avLst/>
-          </a:prstGeom>
-          <a:noFill/>
-        </p:spPr>
-        <p:txBody>
-          <a:bodyPr wrap="square">
-            <a:spAutoFit/>
-          </a:bodyPr>
-          <a:lstStyle/>
-          <a:p>
-            <a:pPr algn="l">
-              <a:defRPr sz="2000" b="1">
-                <a:solidFill>
-                  <a:srgbClr val="2980B9"/>
-                </a:solidFill>
-                <a:latin typeface="Calibri"/>
-              </a:defRPr>
-            </a:pPr>
-            <a:r>
-              <a:t>Безопасность</a:t>
-            </a:r>
-          </a:p>
-        </p:txBody>
-      </p:sp>
-      <p:sp>
-        <p:nvSpPr>
-          <p:cNvPr id="8" name="TextBox 7"/>
-          <p:cNvSpPr txBox="1"/>
-          <p:nvPr/>
-        </p:nvSpPr>
-        <p:spPr>
-          <a:xfrm>
-            <a:off x="6400800" y="1463040"/>
-            <a:ext cx="5029200" cy="365760"/>
-          </a:xfrm>
-          <a:prstGeom prst="rect">
-            <a:avLst/>
-          </a:prstGeom>
-          <a:noFill/>
-        </p:spPr>
-        <p:txBody>
-          <a:bodyPr wrap="square">
-            <a:spAutoFit/>
-          </a:bodyPr>
-          <a:lstStyle/>
-          <a:p>
-            <a:pPr algn="l">
-              <a:defRPr sz="2000" b="1">
-                <a:solidFill>
-                  <a:srgbClr val="2980B9"/>
-                </a:solidFill>
-                <a:latin typeface="Calibri"/>
-              </a:defRPr>
-            </a:pPr>
-            <a:r>
-              <a:t>CI/CD и автоматизация</a:t>
             </a:r>
           </a:p>
         </p:txBody>
@@ -4647,7 +4647,7 @@
               </a:defRPr>
             </a:pPr>
             <a:r>
-              <a:t>ImagingTools GmbH</a:t>
+              <a:t>IronBit OOO</a:t>
             </a:r>
           </a:p>
         </p:txBody>
@@ -4683,7 +4683,7 @@
               </a:defRPr>
             </a:pPr>
             <a:r>
-              <a:t>Штокдорф, Германия</a:t>
+              <a:t>Омск, Россия</a:t>
             </a:r>
             <a:br/>
             <a:r>
@@ -4827,7 +4827,7 @@
               </a:defRPr>
             </a:pPr>
             <a:r>
-              <a:t>О компании ImagingTools GmbH</a:t>
+              <a:t>О компании IronBit OOO</a:t>
             </a:r>
           </a:p>
         </p:txBody>
@@ -4863,7 +4863,7 @@
               </a:defRPr>
             </a:pPr>
             <a:r>
-              <a:t>ImagingTools GmbH — технологическая компания, специализирующаяся на разработке высококачественных программных инструментов и фреймворков для промышленных приложений и компонентного программирования.</a:t>
+              <a:t>IronBit OOO — технологическая компания, специализирующаяся на разработке высококачественных программных инструментов и фреймворков для промышленных приложений и компонентного программирования.</a:t>
             </a:r>
           </a:p>
         </p:txBody>
@@ -6745,7 +6745,7 @@
               </a:defRPr>
             </a:pPr>
             <a:r>
-              <a:t>Собственный компонентный фреймворк промышленного уровня. Основа всех продуктов ImagingTools. Более 20 библиотек. Лицензия LGPL-2.1.</a:t>
+              <a:t>Собственный компонентный фреймворк промышленного уровня. Основа всех продуктов IronBit. Более 20 библиотек. Лицензия LGPL-2.1.</a:t>
             </a:r>
           </a:p>
         </p:txBody>

</xml_diff>